<commit_message>
fix: GroupShuffleSplit по client_id, ROC-AUC 0.7197, синхронизация цифр
</commit_message>
<xml_diff>
--- a/sber_autoподписка_hackathon.pptx
+++ b/sber_autoподписка_hackathon.pptx
@@ -2099,6 +2099,10 @@
             <a:prstDash val="solid"/>
           </a:ln>
         </p:spPr>
+        <p:txBody>
+          <a:bodyPr/>
+          <a:p/>
+        </p:txBody>
       </p:sp>
       <p:sp>
         <p:nvSpPr>
@@ -2128,6 +2132,10 @@
             <a:prstDash val="solid"/>
           </a:ln>
         </p:spPr>
+        <p:txBody>
+          <a:bodyPr/>
+          <a:p/>
+        </p:txBody>
       </p:sp>
       <p:sp>
         <p:nvSpPr>
@@ -2157,6 +2165,10 @@
             <a:prstDash val="solid"/>
           </a:ln>
         </p:spPr>
+        <p:txBody>
+          <a:bodyPr/>
+          <a:p/>
+        </p:txBody>
       </p:sp>
       <p:sp>
         <p:nvSpPr>
@@ -2184,6 +2196,10 @@
             <a:prstDash val="solid"/>
           </a:ln>
         </p:spPr>
+        <p:txBody>
+          <a:bodyPr/>
+          <a:p/>
+        </p:txBody>
       </p:sp>
       <p:sp>
         <p:nvSpPr>
@@ -2379,6 +2395,10 @@
             <a:prstDash val="solid"/>
           </a:ln>
         </p:spPr>
+        <p:txBody>
+          <a:bodyPr/>
+          <a:p/>
+        </p:txBody>
       </p:sp>
       <p:sp>
         <p:nvSpPr>
@@ -2406,6 +2426,10 @@
             <a:prstDash val="solid"/>
           </a:ln>
         </p:spPr>
+        <p:txBody>
+          <a:bodyPr/>
+          <a:p/>
+        </p:txBody>
       </p:sp>
       <p:sp>
         <p:nvSpPr>
@@ -2469,6 +2493,10 @@
             <a:prstDash val="solid"/>
           </a:ln>
         </p:spPr>
+        <p:txBody>
+          <a:bodyPr/>
+          <a:p/>
+        </p:txBody>
       </p:sp>
       <p:sp>
         <p:nvSpPr>
@@ -2500,7 +2528,7 @@
                   <a:srgbClr val="CADCFC"/>
                 </a:solidFill>
               </a:rPr>
-              <a:t>ROC-AUC 0.7289</a:t>
+              <a:t>ROC-AUC 0.7197</a:t>
             </a:r>
             <a:endParaRPr lang="en-US" sz="1150" dirty="0"/>
           </a:p>
@@ -2532,6 +2560,10 @@
             <a:prstDash val="solid"/>
           </a:ln>
         </p:spPr>
+        <p:txBody>
+          <a:bodyPr/>
+          <a:p/>
+        </p:txBody>
       </p:sp>
       <p:sp>
         <p:nvSpPr>
@@ -2599,7 +2631,7 @@
                   <a:srgbClr val="64748B"/>
                 </a:solidFill>
               </a:rPr>
-              <a:t>Машинное обучение · </a:t>
+              <a:t xml:space="preserve">Машинное обучение · </a:t>
             </a:r>
             <a:r>
               <a:rPr lang="ru-RU" sz="1000" dirty="0">
@@ -2607,7 +2639,7 @@
                   <a:srgbClr val="64748B"/>
                 </a:solidFill>
               </a:rPr>
-              <a:t>МИФИ / </a:t>
+              <a:t xml:space="preserve">МИФИ / </a:t>
             </a:r>
             <a:r>
               <a:rPr lang="en-US" sz="1000" dirty="0">
@@ -2623,7 +2655,7 @@
                   <a:srgbClr val="64748B"/>
                 </a:solidFill>
               </a:rPr>
-              <a:t> </a:t>
+              <a:t xml:space="preserve"> </a:t>
             </a:r>
             <a:r>
               <a:rPr lang="en-US" sz="1000" dirty="0">
@@ -2639,7 +2671,7 @@
                   <a:srgbClr val="64748B"/>
                 </a:solidFill>
               </a:rPr>
-              <a:t> Бегали уулу Манас </a:t>
+              <a:t xml:space="preserve"> Бегали уулу Манас </a:t>
             </a:r>
             <a:r>
               <a:rPr lang="en-US" sz="1000" dirty="0">
@@ -2710,6 +2742,10 @@
             <a:prstDash val="solid"/>
           </a:ln>
         </p:spPr>
+        <p:txBody>
+          <a:bodyPr/>
+          <a:p/>
+        </p:txBody>
       </p:sp>
       <p:sp>
         <p:nvSpPr>
@@ -2771,6 +2807,10 @@
             <a:prstDash val="solid"/>
           </a:ln>
         </p:spPr>
+        <p:txBody>
+          <a:bodyPr/>
+          <a:p/>
+        </p:txBody>
       </p:sp>
       <p:sp>
         <p:nvSpPr>
@@ -2803,6 +2843,10 @@
             </a:outerShdw>
           </a:effectLst>
         </p:spPr>
+        <p:txBody>
+          <a:bodyPr/>
+          <a:p/>
+        </p:txBody>
       </p:sp>
       <p:sp>
         <p:nvSpPr>
@@ -2900,6 +2944,10 @@
             <a:prstDash val="solid"/>
           </a:ln>
         </p:spPr>
+        <p:txBody>
+          <a:bodyPr/>
+          <a:p/>
+        </p:txBody>
       </p:sp>
       <p:sp>
         <p:nvSpPr>
@@ -3045,7 +3093,7 @@
                   <a:srgbClr val="1E2761"/>
                 </a:solidFill>
               </a:rPr>
-              <a:t>Построить модель, предсказывающую вероятность </a:t>
+              <a:t xml:space="preserve">Построить модель, предсказывающую вероятность </a:t>
             </a:r>
             <a:r>
               <a:rPr lang="en-US" sz="1200" b="1" dirty="0">
@@ -3061,7 +3109,7 @@
                   <a:srgbClr val="1E2761"/>
                 </a:solidFill>
               </a:rPr>
-              <a:t> пользователя на сайте.</a:t>
+              <a:t xml:space="preserve"> пользователя на сайте.</a:t>
             </a:r>
             <a:endParaRPr lang="en-US" sz="1200" dirty="0"/>
           </a:p>
@@ -3098,6 +3146,10 @@
             </a:outerShdw>
           </a:effectLst>
         </p:spPr>
+        <p:txBody>
+          <a:bodyPr/>
+          <a:p/>
+        </p:txBody>
       </p:sp>
       <p:sp>
         <p:nvSpPr>
@@ -3159,6 +3211,10 @@
             <a:prstDash val="solid"/>
           </a:ln>
         </p:spPr>
+        <p:txBody>
+          <a:bodyPr/>
+          <a:p/>
+        </p:txBody>
       </p:sp>
       <p:sp>
         <p:nvSpPr>
@@ -3256,6 +3312,10 @@
             <a:prstDash val="solid"/>
           </a:ln>
         </p:spPr>
+        <p:txBody>
+          <a:bodyPr/>
+          <a:p/>
+        </p:txBody>
       </p:sp>
       <p:sp>
         <p:nvSpPr>
@@ -3353,6 +3413,10 @@
             <a:prstDash val="solid"/>
           </a:ln>
         </p:spPr>
+        <p:txBody>
+          <a:bodyPr/>
+          <a:p/>
+        </p:txBody>
       </p:sp>
       <p:sp>
         <p:nvSpPr>
@@ -3452,6 +3516,10 @@
             <a:prstDash val="solid"/>
           </a:ln>
         </p:spPr>
+        <p:txBody>
+          <a:bodyPr/>
+          <a:p/>
+        </p:txBody>
       </p:sp>
       <p:sp>
         <p:nvSpPr>
@@ -3546,6 +3614,10 @@
             <a:prstDash val="solid"/>
           </a:ln>
         </p:spPr>
+        <p:txBody>
+          <a:bodyPr/>
+          <a:p/>
+        </p:txBody>
       </p:sp>
       <p:sp>
         <p:nvSpPr>
@@ -3607,6 +3679,10 @@
             <a:prstDash val="solid"/>
           </a:ln>
         </p:spPr>
+        <p:txBody>
+          <a:bodyPr/>
+          <a:p/>
+        </p:txBody>
       </p:sp>
       <p:sp>
         <p:nvSpPr>
@@ -3639,6 +3715,10 @@
             </a:outerShdw>
           </a:effectLst>
         </p:spPr>
+        <p:txBody>
+          <a:bodyPr/>
+          <a:p/>
+        </p:txBody>
       </p:sp>
       <p:sp>
         <p:nvSpPr>
@@ -3664,6 +3744,10 @@
             <a:prstDash val="solid"/>
           </a:ln>
         </p:spPr>
+        <p:txBody>
+          <a:bodyPr/>
+          <a:p/>
+        </p:txBody>
       </p:sp>
       <p:sp>
         <p:nvSpPr>
@@ -3804,6 +3888,10 @@
             </a:outerShdw>
           </a:effectLst>
         </p:spPr>
+        <p:txBody>
+          <a:bodyPr/>
+          <a:p/>
+        </p:txBody>
       </p:sp>
       <p:sp>
         <p:nvSpPr>
@@ -3829,6 +3917,10 @@
             <a:prstDash val="solid"/>
           </a:ln>
         </p:spPr>
+        <p:txBody>
+          <a:bodyPr/>
+          <a:p/>
+        </p:txBody>
       </p:sp>
       <p:sp>
         <p:nvSpPr>
@@ -3969,6 +4061,10 @@
             </a:outerShdw>
           </a:effectLst>
         </p:spPr>
+        <p:txBody>
+          <a:bodyPr/>
+          <a:p/>
+        </p:txBody>
       </p:sp>
       <p:sp>
         <p:nvSpPr>
@@ -3994,6 +4090,10 @@
             <a:prstDash val="solid"/>
           </a:ln>
         </p:spPr>
+        <p:txBody>
+          <a:bodyPr/>
+          <a:p/>
+        </p:txBody>
       </p:sp>
       <p:sp>
         <p:nvSpPr>
@@ -4134,6 +4234,10 @@
             </a:outerShdw>
           </a:effectLst>
         </p:spPr>
+        <p:txBody>
+          <a:bodyPr/>
+          <a:p/>
+        </p:txBody>
       </p:sp>
       <p:sp>
         <p:nvSpPr>
@@ -4159,6 +4263,10 @@
             <a:prstDash val="solid"/>
           </a:ln>
         </p:spPr>
+        <p:txBody>
+          <a:bodyPr/>
+          <a:p/>
+        </p:txBody>
       </p:sp>
       <p:sp>
         <p:nvSpPr>
@@ -4335,6 +4443,10 @@
             </a:outerShdw>
           </a:effectLst>
         </p:spPr>
+        <p:txBody>
+          <a:bodyPr/>
+          <a:p/>
+        </p:txBody>
       </p:sp>
       <p:sp>
         <p:nvSpPr>
@@ -4360,6 +4472,10 @@
             <a:prstDash val="solid"/>
           </a:ln>
         </p:spPr>
+        <p:txBody>
+          <a:bodyPr/>
+          <a:p/>
+        </p:txBody>
       </p:sp>
       <p:sp>
         <p:nvSpPr>
@@ -4464,6 +4580,10 @@
             </a:outerShdw>
           </a:effectLst>
         </p:spPr>
+        <p:txBody>
+          <a:bodyPr/>
+          <a:p/>
+        </p:txBody>
       </p:sp>
       <p:sp>
         <p:nvSpPr>
@@ -4489,6 +4609,10 @@
             <a:prstDash val="solid"/>
           </a:ln>
         </p:spPr>
+        <p:txBody>
+          <a:bodyPr/>
+          <a:p/>
+        </p:txBody>
       </p:sp>
       <p:sp>
         <p:nvSpPr>
@@ -4593,6 +4717,10 @@
             </a:outerShdw>
           </a:effectLst>
         </p:spPr>
+        <p:txBody>
+          <a:bodyPr/>
+          <a:p/>
+        </p:txBody>
       </p:sp>
       <p:sp>
         <p:nvSpPr>
@@ -4618,6 +4746,10 @@
             <a:prstDash val="solid"/>
           </a:ln>
         </p:spPr>
+        <p:txBody>
+          <a:bodyPr/>
+          <a:p/>
+        </p:txBody>
       </p:sp>
       <p:sp>
         <p:nvSpPr>
@@ -4722,6 +4854,10 @@
             </a:outerShdw>
           </a:effectLst>
         </p:spPr>
+        <p:txBody>
+          <a:bodyPr/>
+          <a:p/>
+        </p:txBody>
       </p:sp>
       <p:sp>
         <p:nvSpPr>
@@ -4747,6 +4883,10 @@
             <a:prstDash val="solid"/>
           </a:ln>
         </p:spPr>
+        <p:txBody>
+          <a:bodyPr/>
+          <a:p/>
+        </p:txBody>
       </p:sp>
       <p:sp>
         <p:nvSpPr>
@@ -4851,6 +4991,10 @@
             </a:outerShdw>
           </a:effectLst>
         </p:spPr>
+        <p:txBody>
+          <a:bodyPr/>
+          <a:p/>
+        </p:txBody>
       </p:sp>
       <p:sp>
         <p:nvSpPr>
@@ -4876,6 +5020,10 @@
             <a:prstDash val="solid"/>
           </a:ln>
         </p:spPr>
+        <p:txBody>
+          <a:bodyPr/>
+          <a:p/>
+        </p:txBody>
       </p:sp>
       <p:sp>
         <p:nvSpPr>
@@ -4980,6 +5128,10 @@
             </a:outerShdw>
           </a:effectLst>
         </p:spPr>
+        <p:txBody>
+          <a:bodyPr/>
+          <a:p/>
+        </p:txBody>
       </p:sp>
       <p:sp>
         <p:nvSpPr>
@@ -5005,6 +5157,10 @@
             <a:prstDash val="solid"/>
           </a:ln>
         </p:spPr>
+        <p:txBody>
+          <a:bodyPr/>
+          <a:p/>
+        </p:txBody>
       </p:sp>
       <p:sp>
         <p:nvSpPr>
@@ -5135,6 +5291,10 @@
             <a:prstDash val="solid"/>
           </a:ln>
         </p:spPr>
+        <p:txBody>
+          <a:bodyPr/>
+          <a:p/>
+        </p:txBody>
       </p:sp>
       <p:sp>
         <p:nvSpPr>
@@ -5196,6 +5356,10 @@
             <a:prstDash val="solid"/>
           </a:ln>
         </p:spPr>
+        <p:txBody>
+          <a:bodyPr/>
+          <a:p/>
+        </p:txBody>
       </p:sp>
       <p:sp>
         <p:nvSpPr>
@@ -5221,6 +5385,10 @@
             <a:prstDash val="solid"/>
           </a:ln>
         </p:spPr>
+        <p:txBody>
+          <a:bodyPr/>
+          <a:p/>
+        </p:txBody>
       </p:sp>
       <p:sp>
         <p:nvSpPr>
@@ -5252,7 +5420,7 @@
                   <a:srgbClr val="02C39A"/>
                 </a:solidFill>
               </a:rPr>
-              <a:t>Итого: 23 признака для модели  |  </a:t>
+              <a:t xml:space="preserve">Итого: 23 признака для модели  |  </a:t>
             </a:r>
             <a:r>
               <a:rPr lang="ru-RU" sz="1200" b="1" dirty="0">
@@ -5268,7 +5436,7 @@
                   <a:srgbClr val="02C39A"/>
                 </a:solidFill>
               </a:rPr>
-              <a:t> </a:t>
+              <a:t xml:space="preserve"> </a:t>
             </a:r>
             <a:r>
               <a:rPr lang="en-US" sz="1200" b="1" dirty="0" err="1">
@@ -5284,7 +5452,7 @@
                   <a:srgbClr val="02C39A"/>
                 </a:solidFill>
               </a:rPr>
-              <a:t>  +  7 </a:t>
+              <a:t xml:space="preserve">  +  7 </a:t>
             </a:r>
             <a:r>
               <a:rPr lang="en-US" sz="1200" b="1" dirty="0" err="1">
@@ -5322,6 +5490,10 @@
             <a:prstDash val="solid"/>
           </a:ln>
         </p:spPr>
+        <p:txBody>
+          <a:bodyPr/>
+          <a:p/>
+        </p:txBody>
       </p:sp>
       <p:sp>
         <p:nvSpPr>
@@ -5399,6 +5571,10 @@
             <a:prstDash val="solid"/>
           </a:ln>
         </p:spPr>
+        <p:txBody>
+          <a:bodyPr/>
+          <a:p/>
+        </p:txBody>
       </p:sp>
       <p:sp>
         <p:nvSpPr>
@@ -5496,6 +5672,10 @@
             <a:prstDash val="solid"/>
           </a:ln>
         </p:spPr>
+        <p:txBody>
+          <a:bodyPr/>
+          <a:p/>
+        </p:txBody>
       </p:sp>
       <p:sp>
         <p:nvSpPr>
@@ -5593,6 +5773,10 @@
             <a:prstDash val="solid"/>
           </a:ln>
         </p:spPr>
+        <p:txBody>
+          <a:bodyPr/>
+          <a:p/>
+        </p:txBody>
       </p:sp>
       <p:sp>
         <p:nvSpPr>
@@ -5690,6 +5874,10 @@
             <a:prstDash val="solid"/>
           </a:ln>
         </p:spPr>
+        <p:txBody>
+          <a:bodyPr/>
+          <a:p/>
+        </p:txBody>
       </p:sp>
       <p:sp>
         <p:nvSpPr>
@@ -5787,6 +5975,10 @@
             <a:prstDash val="solid"/>
           </a:ln>
         </p:spPr>
+        <p:txBody>
+          <a:bodyPr/>
+          <a:p/>
+        </p:txBody>
       </p:sp>
       <p:sp>
         <p:nvSpPr>
@@ -5884,6 +6076,10 @@
             <a:prstDash val="solid"/>
           </a:ln>
         </p:spPr>
+        <p:txBody>
+          <a:bodyPr/>
+          <a:p/>
+        </p:txBody>
       </p:sp>
       <p:sp>
         <p:nvSpPr>
@@ -5981,6 +6177,10 @@
             <a:prstDash val="solid"/>
           </a:ln>
         </p:spPr>
+        <p:txBody>
+          <a:bodyPr/>
+          <a:p/>
+        </p:txBody>
       </p:sp>
       <p:sp>
         <p:nvSpPr>
@@ -6078,6 +6278,10 @@
             <a:prstDash val="solid"/>
           </a:ln>
         </p:spPr>
+        <p:txBody>
+          <a:bodyPr/>
+          <a:p/>
+        </p:txBody>
       </p:sp>
       <p:sp>
         <p:nvSpPr>
@@ -6175,6 +6379,10 @@
             <a:prstDash val="solid"/>
           </a:ln>
         </p:spPr>
+        <p:txBody>
+          <a:bodyPr/>
+          <a:p/>
+        </p:txBody>
       </p:sp>
       <p:sp>
         <p:nvSpPr>
@@ -6272,6 +6480,10 @@
             <a:prstDash val="solid"/>
           </a:ln>
         </p:spPr>
+        <p:txBody>
+          <a:bodyPr/>
+          <a:p/>
+        </p:txBody>
       </p:sp>
       <p:sp>
         <p:nvSpPr>
@@ -6371,6 +6583,10 @@
             <a:prstDash val="solid"/>
           </a:ln>
         </p:spPr>
+        <p:txBody>
+          <a:bodyPr/>
+          <a:p/>
+        </p:txBody>
       </p:sp>
       <p:sp>
         <p:nvSpPr>
@@ -6432,6 +6648,10 @@
             <a:prstDash val="solid"/>
           </a:ln>
         </p:spPr>
+        <p:txBody>
+          <a:bodyPr/>
+          <a:p/>
+        </p:txBody>
       </p:sp>
       <p:sp>
         <p:nvSpPr>
@@ -6529,6 +6749,10 @@
             <a:prstDash val="solid"/>
           </a:ln>
         </p:spPr>
+        <p:txBody>
+          <a:bodyPr/>
+          <a:p/>
+        </p:txBody>
       </p:sp>
       <p:sp>
         <p:nvSpPr>
@@ -6626,6 +6850,10 @@
             <a:prstDash val="solid"/>
           </a:ln>
         </p:spPr>
+        <p:txBody>
+          <a:bodyPr/>
+          <a:p/>
+        </p:txBody>
       </p:sp>
       <p:sp>
         <p:nvSpPr>
@@ -6723,6 +6951,10 @@
             <a:prstDash val="solid"/>
           </a:ln>
         </p:spPr>
+        <p:txBody>
+          <a:bodyPr/>
+          <a:p/>
+        </p:txBody>
       </p:sp>
       <p:sp>
         <p:nvSpPr>
@@ -6820,6 +7052,10 @@
             <a:prstDash val="solid"/>
           </a:ln>
         </p:spPr>
+        <p:txBody>
+          <a:bodyPr/>
+          <a:p/>
+        </p:txBody>
       </p:sp>
       <p:sp>
         <p:nvSpPr>
@@ -6917,6 +7153,10 @@
             <a:prstDash val="solid"/>
           </a:ln>
         </p:spPr>
+        <p:txBody>
+          <a:bodyPr/>
+          <a:p/>
+        </p:txBody>
       </p:sp>
       <p:sp>
         <p:nvSpPr>
@@ -7014,6 +7254,10 @@
             <a:prstDash val="solid"/>
           </a:ln>
         </p:spPr>
+        <p:txBody>
+          <a:bodyPr/>
+          <a:p/>
+        </p:txBody>
       </p:sp>
       <p:sp>
         <p:nvSpPr>
@@ -7115,6 +7359,10 @@
             <a:prstDash val="solid"/>
           </a:ln>
         </p:spPr>
+        <p:txBody>
+          <a:bodyPr/>
+          <a:p/>
+        </p:txBody>
       </p:sp>
       <p:sp>
         <p:nvSpPr>
@@ -7209,6 +7457,10 @@
             <a:prstDash val="solid"/>
           </a:ln>
         </p:spPr>
+        <p:txBody>
+          <a:bodyPr/>
+          <a:p/>
+        </p:txBody>
       </p:sp>
       <p:sp>
         <p:nvSpPr>
@@ -7270,6 +7522,10 @@
             <a:prstDash val="solid"/>
           </a:ln>
         </p:spPr>
+        <p:txBody>
+          <a:bodyPr/>
+          <a:p/>
+        </p:txBody>
       </p:sp>
       <p:sp>
         <p:nvSpPr>
@@ -7302,6 +7558,10 @@
             </a:outerShdw>
           </a:effectLst>
         </p:spPr>
+        <p:txBody>
+          <a:bodyPr/>
+          <a:p/>
+        </p:txBody>
       </p:sp>
       <p:sp>
         <p:nvSpPr>
@@ -7327,6 +7587,10 @@
             <a:prstDash val="solid"/>
           </a:ln>
         </p:spPr>
+        <p:txBody>
+          <a:bodyPr/>
+          <a:p/>
+        </p:txBody>
       </p:sp>
       <p:sp>
         <p:nvSpPr>
@@ -7394,7 +7658,7 @@
                   <a:srgbClr val="1E2761"/>
                 </a:solidFill>
               </a:rPr>
-              <a:t>Train: 1 488 033 строк</a:t>
+              <a:t>Train: 1 487 448 строк</a:t>
             </a:r>
             <a:endParaRPr lang="en-US" sz="1100" dirty="0"/>
           </a:p>
@@ -7408,7 +7672,7 @@
                   <a:srgbClr val="1E2761"/>
                 </a:solidFill>
               </a:rPr>
-              <a:t>Test:    372 009 строк</a:t>
+              <a:t>Test:    372 594 строк</a:t>
             </a:r>
             <a:endParaRPr lang="en-US" sz="1100" dirty="0"/>
           </a:p>
@@ -7422,7 +7686,7 @@
                   <a:srgbClr val="1E2761"/>
                 </a:solidFill>
               </a:rPr>
-              <a:t>Стратификация: 80/20</a:t>
+              <a:t>GroupShuffleSplit по client_id (80/20)</a:t>
             </a:r>
             <a:endParaRPr lang="en-US" sz="1100" dirty="0"/>
           </a:p>
@@ -7473,6 +7737,10 @@
             </a:outerShdw>
           </a:effectLst>
         </p:spPr>
+        <p:txBody>
+          <a:bodyPr/>
+          <a:p/>
+        </p:txBody>
       </p:sp>
       <p:sp>
         <p:nvSpPr>
@@ -7498,6 +7766,10 @@
             <a:prstDash val="solid"/>
           </a:ln>
         </p:spPr>
+        <p:txBody>
+          <a:bodyPr/>
+          <a:p/>
+        </p:txBody>
       </p:sp>
       <p:sp>
         <p:nvSpPr>
@@ -7619,7 +7891,7 @@
                 <a:ea typeface="Consolas" pitchFamily="34" charset="-122"/>
                 <a:cs typeface="Consolas" pitchFamily="34" charset="-120"/>
               </a:rPr>
-              <a:t>scale_pos_weight: 46.7</a:t>
+              <a:t>scale_pos_weight: 46.8</a:t>
             </a:r>
             <a:endParaRPr lang="en-US" sz="1100" dirty="0"/>
           </a:p>
@@ -7656,6 +7928,10 @@
             </a:outerShdw>
           </a:effectLst>
         </p:spPr>
+        <p:txBody>
+          <a:bodyPr/>
+          <a:p/>
+        </p:txBody>
       </p:sp>
       <p:sp>
         <p:nvSpPr>
@@ -7681,6 +7957,10 @@
             <a:prstDash val="solid"/>
           </a:ln>
         </p:spPr>
+        <p:txBody>
+          <a:bodyPr/>
+          <a:p/>
+        </p:txBody>
       </p:sp>
       <p:sp>
         <p:nvSpPr>
@@ -7748,7 +8028,7 @@
                   <a:srgbClr val="02C39A"/>
                 </a:solidFill>
               </a:rPr>
-              <a:t>0.7289</a:t>
+              <a:t>0.7197</a:t>
             </a:r>
             <a:endParaRPr lang="en-US" sz="4400" dirty="0"/>
           </a:p>
@@ -7784,7 +8064,7 @@
                   <a:srgbClr val="CADCFC"/>
                 </a:solidFill>
               </a:rPr>
-              <a:t>Цель была ≥ 0.65  →  превышена на +0.079</a:t>
+              <a:t>Цель была ≥ 0.65  →  превышена на +0.070</a:t>
             </a:r>
             <a:endParaRPr lang="en-US" sz="900" dirty="0"/>
           </a:p>
@@ -7821,6 +8101,10 @@
             </a:outerShdw>
           </a:effectLst>
         </p:spPr>
+        <p:txBody>
+          <a:bodyPr/>
+          <a:p/>
+        </p:txBody>
       </p:sp>
       <p:sp>
         <p:nvSpPr>
@@ -7905,6 +8189,10 @@
             </a:outerShdw>
           </a:effectLst>
         </p:spPr>
+        <p:txBody>
+          <a:bodyPr/>
+          <a:p/>
+        </p:txBody>
       </p:sp>
       <p:sp>
         <p:nvSpPr>
@@ -8015,6 +8303,10 @@
             <a:prstDash val="solid"/>
           </a:ln>
         </p:spPr>
+        <p:txBody>
+          <a:bodyPr/>
+          <a:p/>
+        </p:txBody>
       </p:sp>
       <p:sp>
         <p:nvSpPr>
@@ -8076,6 +8368,10 @@
             <a:prstDash val="solid"/>
           </a:ln>
         </p:spPr>
+        <p:txBody>
+          <a:bodyPr/>
+          <a:p/>
+        </p:txBody>
       </p:sp>
       <p:sp>
         <p:nvSpPr>
@@ -8108,6 +8404,10 @@
             </a:outerShdw>
           </a:effectLst>
         </p:spPr>
+        <p:txBody>
+          <a:bodyPr/>
+          <a:p/>
+        </p:txBody>
       </p:sp>
       <p:sp>
         <p:nvSpPr>
@@ -8192,6 +8492,10 @@
             </a:outerShdw>
           </a:effectLst>
         </p:spPr>
+        <p:txBody>
+          <a:bodyPr/>
+          <a:p/>
+        </p:txBody>
       </p:sp>
       <p:sp>
         <p:nvSpPr>
@@ -8305,6 +8609,10 @@
             <a:prstDash val="solid"/>
           </a:ln>
         </p:spPr>
+        <p:txBody>
+          <a:bodyPr/>
+          <a:p/>
+        </p:txBody>
       </p:sp>
       <p:sp>
         <p:nvSpPr>
@@ -8330,6 +8638,10 @@
             <a:prstDash val="solid"/>
           </a:ln>
         </p:spPr>
+        <p:txBody>
+          <a:bodyPr/>
+          <a:p/>
+        </p:txBody>
       </p:sp>
       <p:sp>
         <p:nvSpPr>
@@ -8465,6 +8777,10 @@
             <a:prstDash val="solid"/>
           </a:ln>
         </p:spPr>
+        <p:txBody>
+          <a:bodyPr/>
+          <a:p/>
+        </p:txBody>
       </p:sp>
       <p:sp>
         <p:nvSpPr>
@@ -8490,6 +8806,10 @@
             <a:prstDash val="solid"/>
           </a:ln>
         </p:spPr>
+        <p:txBody>
+          <a:bodyPr/>
+          <a:p/>
+        </p:txBody>
       </p:sp>
       <p:sp>
         <p:nvSpPr>
@@ -8625,6 +8945,10 @@
             <a:prstDash val="solid"/>
           </a:ln>
         </p:spPr>
+        <p:txBody>
+          <a:bodyPr/>
+          <a:p/>
+        </p:txBody>
       </p:sp>
       <p:sp>
         <p:nvSpPr>
@@ -8650,6 +8974,10 @@
             <a:prstDash val="solid"/>
           </a:ln>
         </p:spPr>
+        <p:txBody>
+          <a:bodyPr/>
+          <a:p/>
+        </p:txBody>
       </p:sp>
       <p:sp>
         <p:nvSpPr>
@@ -8785,6 +9113,10 @@
             <a:prstDash val="solid"/>
           </a:ln>
         </p:spPr>
+        <p:txBody>
+          <a:bodyPr/>
+          <a:p/>
+        </p:txBody>
       </p:sp>
       <p:sp>
         <p:nvSpPr>
@@ -8810,6 +9142,10 @@
             <a:prstDash val="solid"/>
           </a:ln>
         </p:spPr>
+        <p:txBody>
+          <a:bodyPr/>
+          <a:p/>
+        </p:txBody>
       </p:sp>
       <p:sp>
         <p:nvSpPr>
@@ -8945,6 +9281,10 @@
             <a:prstDash val="solid"/>
           </a:ln>
         </p:spPr>
+        <p:txBody>
+          <a:bodyPr/>
+          <a:p/>
+        </p:txBody>
       </p:sp>
       <p:sp>
         <p:nvSpPr>
@@ -8970,6 +9310,10 @@
             <a:prstDash val="solid"/>
           </a:ln>
         </p:spPr>
+        <p:txBody>
+          <a:bodyPr/>
+          <a:p/>
+        </p:txBody>
       </p:sp>
       <p:sp>
         <p:nvSpPr>
@@ -9136,6 +9480,10 @@
             <a:prstDash val="solid"/>
           </a:ln>
         </p:spPr>
+        <p:txBody>
+          <a:bodyPr/>
+          <a:p/>
+        </p:txBody>
       </p:sp>
       <p:sp>
         <p:nvSpPr>
@@ -9197,6 +9545,10 @@
             <a:prstDash val="solid"/>
           </a:ln>
         </p:spPr>
+        <p:txBody>
+          <a:bodyPr/>
+          <a:p/>
+        </p:txBody>
       </p:sp>
       <p:sp>
         <p:nvSpPr>
@@ -9229,6 +9581,10 @@
             </a:outerShdw>
           </a:effectLst>
         </p:spPr>
+        <p:txBody>
+          <a:bodyPr/>
+          <a:p/>
+        </p:txBody>
       </p:sp>
       <p:sp>
         <p:nvSpPr>
@@ -9254,6 +9610,10 @@
             <a:prstDash val="solid"/>
           </a:ln>
         </p:spPr>
+        <p:txBody>
+          <a:bodyPr/>
+          <a:p/>
+        </p:txBody>
       </p:sp>
       <p:sp>
         <p:nvSpPr>
@@ -9444,6 +9804,10 @@
             </a:outerShdw>
           </a:effectLst>
         </p:spPr>
+        <p:txBody>
+          <a:bodyPr/>
+          <a:p/>
+        </p:txBody>
       </p:sp>
       <p:sp>
         <p:nvSpPr>
@@ -9469,6 +9833,10 @@
             <a:prstDash val="solid"/>
           </a:ln>
         </p:spPr>
+        <p:txBody>
+          <a:bodyPr/>
+          <a:p/>
+        </p:txBody>
       </p:sp>
       <p:sp>
         <p:nvSpPr>
@@ -9659,6 +10027,10 @@
             </a:outerShdw>
           </a:effectLst>
         </p:spPr>
+        <p:txBody>
+          <a:bodyPr/>
+          <a:p/>
+        </p:txBody>
       </p:sp>
       <p:sp>
         <p:nvSpPr>
@@ -9684,6 +10056,10 @@
             <a:prstDash val="solid"/>
           </a:ln>
         </p:spPr>
+        <p:txBody>
+          <a:bodyPr/>
+          <a:p/>
+        </p:txBody>
       </p:sp>
       <p:sp>
         <p:nvSpPr>
@@ -9874,6 +10250,10 @@
             </a:outerShdw>
           </a:effectLst>
         </p:spPr>
+        <p:txBody>
+          <a:bodyPr/>
+          <a:p/>
+        </p:txBody>
       </p:sp>
       <p:sp>
         <p:nvSpPr>
@@ -9899,6 +10279,10 @@
             <a:prstDash val="solid"/>
           </a:ln>
         </p:spPr>
+        <p:txBody>
+          <a:bodyPr/>
+          <a:p/>
+        </p:txBody>
       </p:sp>
       <p:sp>
         <p:nvSpPr>
@@ -10053,6 +10437,10 @@
             </a:outerShdw>
           </a:effectLst>
         </p:spPr>
+        <p:txBody>
+          <a:bodyPr/>
+          <a:p/>
+        </p:txBody>
       </p:sp>
       <p:sp>
         <p:nvSpPr>
@@ -10116,6 +10504,10 @@
             <a:prstDash val="solid"/>
           </a:ln>
         </p:spPr>
+        <p:txBody>
+          <a:bodyPr/>
+          <a:p/>
+        </p:txBody>
       </p:sp>
       <p:sp>
         <p:nvSpPr>
@@ -10254,6 +10646,10 @@
             <a:prstDash val="solid"/>
           </a:ln>
         </p:spPr>
+        <p:txBody>
+          <a:bodyPr/>
+          <a:p/>
+        </p:txBody>
       </p:sp>
       <p:sp>
         <p:nvSpPr>
@@ -10392,6 +10788,10 @@
             <a:prstDash val="solid"/>
           </a:ln>
         </p:spPr>
+        <p:txBody>
+          <a:bodyPr/>
+          <a:p/>
+        </p:txBody>
       </p:sp>
       <p:sp>
         <p:nvSpPr>
@@ -10530,6 +10930,10 @@
             <a:prstDash val="solid"/>
           </a:ln>
         </p:spPr>
+        <p:txBody>
+          <a:bodyPr/>
+          <a:p/>
+        </p:txBody>
       </p:sp>
       <p:sp>
         <p:nvSpPr>
@@ -10673,6 +11077,10 @@
             </a:outerShdw>
           </a:effectLst>
         </p:spPr>
+        <p:txBody>
+          <a:bodyPr/>
+          <a:p/>
+        </p:txBody>
       </p:sp>
       <p:sp>
         <p:nvSpPr>
@@ -10776,7 +11184,7 @@
                   <a:srgbClr val="FFFFFF"/>
                 </a:solidFill>
               </a:rPr>
-              <a:t>5.</a:t>
+              <a:t>5.27 мс</a:t>
             </a:r>
             <a:r>
               <a:rPr lang="ru-RU" sz="1100" b="1" dirty="0">
@@ -10784,7 +11192,7 @@
                   <a:srgbClr val="FFFFFF"/>
                 </a:solidFill>
               </a:rPr>
-              <a:t>88</a:t>
+              <a:t/>
             </a:r>
             <a:r>
               <a:rPr lang="en-US" sz="1100" b="1" dirty="0">
@@ -10792,7 +11200,7 @@
                   <a:srgbClr val="FFFFFF"/>
                 </a:solidFill>
               </a:rPr>
-              <a:t> мс</a:t>
+              <a:t xml:space="preserve"/>
             </a:r>
             <a:endParaRPr lang="en-US" sz="1100" dirty="0"/>
           </a:p>
@@ -10826,6 +11234,10 @@
             <a:prstDash val="solid"/>
           </a:ln>
         </p:spPr>
+        <p:txBody>
+          <a:bodyPr/>
+          <a:p/>
+        </p:txBody>
       </p:sp>
       <p:sp>
         <p:nvSpPr>
@@ -10893,7 +11305,7 @@
                   <a:srgbClr val="FFFFFF"/>
                 </a:solidFill>
               </a:rPr>
-              <a:t>5.20 мс</a:t>
+              <a:t>5.14 мс</a:t>
             </a:r>
             <a:endParaRPr lang="en-US" sz="1100" dirty="0"/>
           </a:p>
@@ -10927,6 +11339,10 @@
             <a:prstDash val="solid"/>
           </a:ln>
         </p:spPr>
+        <p:txBody>
+          <a:bodyPr/>
+          <a:p/>
+        </p:txBody>
       </p:sp>
       <p:sp>
         <p:nvSpPr>
@@ -10994,7 +11410,7 @@
                   <a:srgbClr val="FFFFFF"/>
                 </a:solidFill>
               </a:rPr>
-              <a:t>10.</a:t>
+              <a:t>8.77 мс</a:t>
             </a:r>
             <a:r>
               <a:rPr lang="ru-RU" sz="1100" b="1" dirty="0">
@@ -11002,7 +11418,7 @@
                   <a:srgbClr val="FFFFFF"/>
                 </a:solidFill>
               </a:rPr>
-              <a:t>69</a:t>
+              <a:t/>
             </a:r>
             <a:r>
               <a:rPr lang="en-US" sz="1100" b="1" dirty="0">
@@ -11010,7 +11426,7 @@
                   <a:srgbClr val="FFFFFF"/>
                 </a:solidFill>
               </a:rPr>
-              <a:t> мс</a:t>
+              <a:t xml:space="preserve"/>
             </a:r>
             <a:endParaRPr lang="en-US" sz="1100" dirty="0"/>
           </a:p>
@@ -11044,6 +11460,10 @@
             <a:prstDash val="solid"/>
           </a:ln>
         </p:spPr>
+        <p:txBody>
+          <a:bodyPr/>
+          <a:p/>
+        </p:txBody>
       </p:sp>
       <p:sp>
         <p:nvSpPr>
@@ -11111,7 +11531,7 @@
                   <a:srgbClr val="FFFFFF"/>
                 </a:solidFill>
               </a:rPr>
-              <a:t>6.41 мс</a:t>
+              <a:t>6.46 мс</a:t>
             </a:r>
             <a:endParaRPr lang="en-US" sz="1100" dirty="0"/>
           </a:p>
@@ -11145,6 +11565,10 @@
             <a:prstDash val="solid"/>
           </a:ln>
         </p:spPr>
+        <p:txBody>
+          <a:bodyPr/>
+          <a:p/>
+        </p:txBody>
       </p:sp>
       <p:sp>
         <p:nvSpPr>
@@ -11279,6 +11703,10 @@
             <a:prstDash val="solid"/>
           </a:ln>
         </p:spPr>
+        <p:txBody>
+          <a:bodyPr/>
+          <a:p/>
+        </p:txBody>
       </p:sp>
       <p:sp>
         <p:nvSpPr>
@@ -11308,6 +11736,10 @@
             <a:prstDash val="solid"/>
           </a:ln>
         </p:spPr>
+        <p:txBody>
+          <a:bodyPr/>
+          <a:p/>
+        </p:txBody>
       </p:sp>
       <p:sp>
         <p:nvSpPr>
@@ -11333,6 +11765,10 @@
             <a:prstDash val="solid"/>
           </a:ln>
         </p:spPr>
+        <p:txBody>
+          <a:bodyPr/>
+          <a:p/>
+        </p:txBody>
       </p:sp>
       <p:sp>
         <p:nvSpPr>
@@ -11403,6 +11839,10 @@
             </a:outerShdw>
           </a:effectLst>
         </p:spPr>
+        <p:txBody>
+          <a:bodyPr/>
+          <a:p/>
+        </p:txBody>
       </p:sp>
       <p:sp>
         <p:nvSpPr>
@@ -11434,7 +11874,7 @@
                   <a:srgbClr val="02C39A"/>
                 </a:solidFill>
               </a:rPr>
-              <a:t>0.7289</a:t>
+              <a:t>0.7197</a:t>
             </a:r>
             <a:endParaRPr lang="en-US" sz="2200" dirty="0"/>
           </a:p>
@@ -11545,6 +11985,10 @@
             </a:outerShdw>
           </a:effectLst>
         </p:spPr>
+        <p:txBody>
+          <a:bodyPr/>
+          <a:p/>
+        </p:txBody>
       </p:sp>
       <p:sp>
         <p:nvSpPr>
@@ -11576,7 +12020,7 @@
                   <a:srgbClr val="02C39A"/>
                 </a:solidFill>
               </a:rPr>
-              <a:t>0.6346</a:t>
+              <a:t>0.6305</a:t>
             </a:r>
             <a:endParaRPr lang="en-US" sz="2200" dirty="0"/>
           </a:p>
@@ -11648,7 +12092,7 @@
                   <a:srgbClr val="64748B"/>
                 </a:solidFill>
               </a:rPr>
-              <a:t>прирост +0.0943</a:t>
+              <a:t>прирост +0.0893</a:t>
             </a:r>
             <a:endParaRPr lang="en-US" sz="800" dirty="0"/>
           </a:p>
@@ -11687,6 +12131,10 @@
             </a:outerShdw>
           </a:effectLst>
         </p:spPr>
+        <p:txBody>
+          <a:bodyPr/>
+          <a:p/>
+        </p:txBody>
       </p:sp>
       <p:sp>
         <p:nvSpPr>
@@ -11718,7 +12166,7 @@
                   <a:srgbClr val="02C39A"/>
                 </a:solidFill>
               </a:rPr>
-              <a:t>5.</a:t>
+              <a:t>5.27 мс</a:t>
             </a:r>
             <a:r>
               <a:rPr lang="ru-RU" sz="2200" b="1" dirty="0">
@@ -11726,7 +12174,7 @@
                   <a:srgbClr val="02C39A"/>
                 </a:solidFill>
               </a:rPr>
-              <a:t>88</a:t>
+              <a:t/>
             </a:r>
             <a:r>
               <a:rPr lang="en-US" sz="2200" b="1" dirty="0">
@@ -11734,7 +12182,7 @@
                   <a:srgbClr val="02C39A"/>
                 </a:solidFill>
               </a:rPr>
-              <a:t> мс</a:t>
+              <a:t xml:space="preserve"/>
             </a:r>
             <a:endParaRPr lang="en-US" sz="2200" dirty="0"/>
           </a:p>
@@ -11845,6 +12293,10 @@
             </a:outerShdw>
           </a:effectLst>
         </p:spPr>
+        <p:txBody>
+          <a:bodyPr/>
+          <a:p/>
+        </p:txBody>
       </p:sp>
       <p:sp>
         <p:nvSpPr>
@@ -12014,6 +12466,10 @@
             <a:prstDash val="solid"/>
           </a:ln>
         </p:spPr>
+        <p:txBody>
+          <a:bodyPr/>
+          <a:p/>
+        </p:txBody>
       </p:sp>
       <p:sp>
         <p:nvSpPr>
@@ -12075,6 +12531,10 @@
             <a:prstDash val="solid"/>
           </a:ln>
         </p:spPr>
+        <p:txBody>
+          <a:bodyPr/>
+          <a:p/>
+        </p:txBody>
       </p:sp>
       <p:sp>
         <p:nvSpPr>
@@ -12136,6 +12596,10 @@
             <a:prstDash val="solid"/>
           </a:ln>
         </p:spPr>
+        <p:txBody>
+          <a:bodyPr/>
+          <a:p/>
+        </p:txBody>
       </p:sp>
       <p:sp>
         <p:nvSpPr>
@@ -12197,6 +12661,10 @@
             <a:prstDash val="solid"/>
           </a:ln>
         </p:spPr>
+        <p:txBody>
+          <a:bodyPr/>
+          <a:p/>
+        </p:txBody>
       </p:sp>
       <p:sp>
         <p:nvSpPr>
@@ -12296,6 +12764,10 @@
             <a:prstDash val="solid"/>
           </a:ln>
         </p:spPr>
+        <p:txBody>
+          <a:bodyPr/>
+          <a:p/>
+        </p:txBody>
       </p:sp>
       <p:sp>
         <p:nvSpPr>
@@ -12398,6 +12870,10 @@
             <a:prstDash val="solid"/>
           </a:ln>
         </p:spPr>
+        <p:txBody>
+          <a:bodyPr/>
+          <a:p/>
+        </p:txBody>
       </p:sp>
       <p:sp>
         <p:nvSpPr>
@@ -12500,6 +12976,10 @@
             <a:prstDash val="solid"/>
           </a:ln>
         </p:spPr>
+        <p:txBody>
+          <a:bodyPr/>
+          <a:p/>
+        </p:txBody>
       </p:sp>
       <p:sp>
         <p:nvSpPr>
@@ -12602,6 +13082,10 @@
             <a:prstDash val="solid"/>
           </a:ln>
         </p:spPr>
+        <p:txBody>
+          <a:bodyPr/>
+          <a:p/>
+        </p:txBody>
       </p:sp>
       <p:sp>
         <p:nvSpPr>
@@ -12704,6 +13188,10 @@
             <a:prstDash val="solid"/>
           </a:ln>
         </p:spPr>
+        <p:txBody>
+          <a:bodyPr/>
+          <a:p/>
+        </p:txBody>
       </p:sp>
       <p:sp>
         <p:nvSpPr>
@@ -12806,6 +13294,10 @@
             <a:prstDash val="solid"/>
           </a:ln>
         </p:spPr>
+        <p:txBody>
+          <a:bodyPr/>
+          <a:p/>
+        </p:txBody>
       </p:sp>
       <p:sp>
         <p:nvSpPr>
@@ -12908,6 +13400,10 @@
             <a:prstDash val="solid"/>
           </a:ln>
         </p:spPr>
+        <p:txBody>
+          <a:bodyPr/>
+          <a:p/>
+        </p:txBody>
       </p:sp>
       <p:sp>
         <p:nvSpPr>

</xml_diff>